<commit_message>
Consolidate final Bluesky deliverables
</commit_message>
<xml_diff>
--- a/bluesky_presentazione_final.pptx
+++ b/bluesky_presentazione_final.pptx
@@ -8926,7 +8926,7 @@
                 <a:ea typeface="Aptos" pitchFamily="34" charset="-122"/>
                 <a:cs typeface="Aptos" pitchFamily="34" charset="-120"/>
               </a:rPr>
-              <a:t>→ No 00: CV F1 0,688 · AUC 0,760; pp AUC 0,819.</a:t>
+              <a:t>→ No 00: CV F1 0,688; test F1 0,672 · test AUC 0,753; pp test AUC 0,821.</a:t>
             </a:r>
             <a:endParaRPr lang="en-US" sz="1020"/>
           </a:p>
@@ -24251,18 +24251,7 @@
           <a:bodyPr wrap="square" lIns="36576" tIns="27432" rIns="36576" bIns="27432" rtlCol="0" anchor="ctr"/>
           <a:lstStyle/>
           <a:p>
-            <a:pPr algn="ctr">
-              <a:spcAft>
-                <a:spcPts val="0"/>
-              </a:spcAft>
-            </a:pPr>
-            <a:r>
-              <a:rPr sz="950" b="1">
-                <a:solidFill>
-                  <a:srgbClr val="1F2937"/>
-                </a:solidFill>
-                <a:latin typeface="Aptos"/>
-              </a:rPr>
+            <a:r>
               <a:t>VALIDAZIONE</a:t>
             </a:r>
           </a:p>
@@ -24303,7 +24292,7 @@
                 </a:solidFill>
                 <a:latin typeface="Aptos"/>
               </a:rPr>
-              <a:t>Split 70/30: il 70% va nel training, il 30% resta test. Sul training applico StratifiedKFold 10-fold: il modello viene riaddestrato su 10 divisioni diverse mantenendo bilanciate le classi. Le metriche riportate sono cross-validated sul training.</a:t>
+              <a:t>Split 70/30: il 70% va nel training, il 30% resta test. Sul training applico StratifiedKFold 10-fold: il modello viene riaddestrato su 10 divisioni diverse mantenendo bilanciate le classi. Le metriche CV sono calcolate out-of-fold sul training; dopo il fit finale, le metriche finali sono calcolate sul test held-out.</a:t>
             </a:r>
           </a:p>
         </p:txBody>
@@ -24515,7 +24504,7 @@
                 </a:solidFill>
                 <a:latin typeface="Aptos"/>
               </a:rPr>
-              <a:t>Accuracy</a:t>
+              <a:t>Test Accuracy</a:t>
             </a:r>
           </a:p>
         </p:txBody>
@@ -24641,7 +24630,7 @@
                 </a:solidFill>
                 <a:latin typeface="Aptos"/>
               </a:rPr>
-              <a:t>Precision</a:t>
+              <a:t>Test Precision</a:t>
             </a:r>
           </a:p>
         </p:txBody>
@@ -24681,7 +24670,7 @@
                 </a:solidFill>
                 <a:latin typeface="Aptos"/>
               </a:rPr>
-              <a:t>0,853</a:t>
+              <a:t>0,841</a:t>
             </a:r>
           </a:p>
         </p:txBody>
@@ -24767,7 +24756,7 @@
                 </a:solidFill>
                 <a:latin typeface="Aptos"/>
               </a:rPr>
-              <a:t>Recall</a:t>
+              <a:t>Test Recall</a:t>
             </a:r>
           </a:p>
         </p:txBody>
@@ -24807,7 +24796,7 @@
                 </a:solidFill>
                 <a:latin typeface="Aptos"/>
               </a:rPr>
-              <a:t>0,576</a:t>
+              <a:t>0,559</a:t>
             </a:r>
           </a:p>
         </p:txBody>
@@ -24893,7 +24882,7 @@
                 </a:solidFill>
                 <a:latin typeface="Aptos"/>
               </a:rPr>
-              <a:t>ROC AUC</a:t>
+              <a:t>Test ROC AUC</a:t>
             </a:r>
           </a:p>
         </p:txBody>
@@ -24933,7 +24922,7 @@
                 </a:solidFill>
                 <a:latin typeface="Aptos"/>
               </a:rPr>
-              <a:t>0,760</a:t>
+              <a:t>0,753</a:t>
             </a:r>
           </a:p>
         </p:txBody>
@@ -25019,7 +25008,7 @@
                 </a:solidFill>
                 <a:latin typeface="Aptos"/>
               </a:rPr>
-              <a:t>Confusion matrix cross-validated</a:t>
+              <a:t>Confusion matrix test</a:t>
             </a:r>
           </a:p>
         </p:txBody>
@@ -25410,9 +25399,9 @@
                 </a:solidFill>
                 <a:latin typeface="Aptos"/>
               </a:rPr>
-              <a:t>Precision alta (0,853): quando la RF classifica un account come positivo, spesso è davvero un account che riceverà takedown.
-Recall moderata (0,576): una parte dei positivi non viene intercettata perché non accumula abbastanza blocchi visibili.
-AUC 0,760: il modello separa le due classi meglio del caso, ma non in modo completo.</a:t>
+              <a:t>Precision alta anche sul test (0,841): quando la RF classifica un account come positivo, spesso è davvero un account che riceverà takedown.
+Recall moderata anche sul test (0,559): una parte dei positivi non viene intercettata perché non accumula abbastanza blocchi visibili.
+Test ROC AUC 0,753: il modello separa le due classi meglio del caso, ma non in modo completo.</a:t>
             </a:r>
           </a:p>
         </p:txBody>
@@ -26682,7 +26671,7 @@
                 </a:solidFill>
                 <a:latin typeface="Aptos"/>
               </a:rPr>
-              <a:t>Il gruppo pp è il più classificabile: AUC 0,819 e F1 positivi 0,754. Qui l’account ha sia post sia follower, quindi può accumulare blocchi osservabili.</a:t>
+              <a:t>Il gruppo pp è il più classificabile anche sul test held-out: AUC 0,821 e F1 positivi 0,745. Qui l’account ha sia post sia follower, quindi può accumulare blocchi osservabili.</a:t>
             </a:r>
           </a:p>
         </p:txBody>
@@ -31056,18 +31045,7 @@
           </a:bodyPr>
           <a:lstStyle/>
           <a:p>
-            <a:pPr algn="l">
-              <a:spcAft>
-                <a:spcPts val="0"/>
-              </a:spcAft>
-            </a:pPr>
-            <a:r>
-              <a:rPr sz="880" b="1" i="0">
-                <a:solidFill>
-                  <a:srgbClr val="1F2937"/>
-                </a:solidFill>
-                <a:latin typeface="Aptos"/>
-              </a:rPr>
+            <a:r>
               <a:t>Take-away centrale</a:t>
             </a:r>
           </a:p>
@@ -31360,7 +31338,7 @@
                 </a:solidFill>
                 <a:latin typeface="Aptos"/>
               </a:rPr>
-              <a:t>0,760</a:t>
+              <a:t>0,753</a:t>
             </a:r>
           </a:p>
         </p:txBody>
@@ -31400,7 +31378,7 @@
                 </a:solidFill>
                 <a:latin typeface="Aptos"/>
               </a:rPr>
-              <a:t>ROC AUC globale</a:t>
+              <a:t>ROC AUC test</a:t>
             </a:r>
           </a:p>
         </p:txBody>
@@ -31526,7 +31504,7 @@
                 </a:solidFill>
                 <a:latin typeface="Aptos"/>
               </a:rPr>
-              <a:t>0,819</a:t>
+              <a:t>0,821</a:t>
             </a:r>
           </a:p>
         </p:txBody>
@@ -31566,7 +31544,7 @@
                 </a:solidFill>
                 <a:latin typeface="Aptos"/>
               </a:rPr>
-              <a:t>AUC nel gruppo pp</a:t>
+              <a:t>AUC test nel gruppo pp</a:t>
             </a:r>
           </a:p>
         </p:txBody>
@@ -33334,7 +33312,7 @@
                 </a:solidFill>
                 <a:latin typeface="Aptos"/>
               </a:rPr>
-              <a:t>Evidenza: AUC pp = 0,819 · F1 positivi pp = 0,754</a:t>
+              <a:t>Evidenza: AUC pp test = 0,821 · F1 positivi pp test = 0,745</a:t>
             </a:r>
           </a:p>
         </p:txBody>
@@ -34765,7 +34743,7 @@
                 </a:solidFill>
                 <a:latin typeface="Aptos"/>
               </a:rPr>
-              <a:t>0,853</a:t>
+              <a:t>0,841</a:t>
             </a:r>
           </a:p>
         </p:txBody>
@@ -34931,7 +34909,7 @@
                 </a:solidFill>
                 <a:latin typeface="Aptos"/>
               </a:rPr>
-              <a:t>0,576</a:t>
+              <a:t>0,559</a:t>
             </a:r>
           </a:p>
         </p:txBody>
@@ -35343,7 +35321,7 @@
                 </a:solidFill>
                 <a:latin typeface="Aptos"/>
               </a:rPr>
-              <a:t>AUC 0,819 · F1 positivi 0,754</a:t>
+              <a:t>AUC test 0,821 · F1 positivi test 0,745</a:t>
             </a:r>
           </a:p>
         </p:txBody>

</xml_diff>